<commit_message>
docs(report): convert presentation deck to light mode throughout
</commit_message>
<xml_diff>
--- a/report/marl_pong_presentation.pptx
+++ b/report/marl_pong_presentation.pptx
@@ -173,7 +173,7 @@
           </c:tx>
           <c:spPr>
             <a:solidFill>
-              <a:srgbClr val="50A0FF"/>
+              <a:srgbClr val="2B7FFF"/>
             </a:solidFill>
             <a:effectLst/>
           </c:spPr>
@@ -380,7 +380,7 @@
             <a:pPr>
               <a:defRPr sz="1300" b="0" i="0" u="none" strike="noStrike">
                 <a:solidFill>
-                  <a:srgbClr val="66718A"/>
+                  <a:srgbClr val="5B677F"/>
                 </a:solidFill>
                 <a:latin typeface="Arial"/>
               </a:defRPr>
@@ -434,7 +434,7 @@
             <a:pPr>
               <a:defRPr sz="1200" b="0" i="0" u="none" strike="noStrike">
                 <a:solidFill>
-                  <a:srgbClr val="66718A"/>
+                  <a:srgbClr val="5B677F"/>
                 </a:solidFill>
                 <a:latin typeface="Arial"/>
               </a:defRPr>
@@ -465,7 +465,7 @@
           <a:pPr>
             <a:defRPr sz="1300">
               <a:solidFill>
-                <a:srgbClr val="66718A"/>
+                <a:srgbClr val="5B677F"/>
               </a:solidFill>
             </a:defRPr>
           </a:pPr>
@@ -548,7 +548,7 @@
           </c:tx>
           <c:spPr>
             <a:solidFill>
-              <a:srgbClr val="50A0FF"/>
+              <a:srgbClr val="2B7FFF"/>
             </a:solidFill>
             <a:effectLst/>
           </c:spPr>
@@ -631,7 +631,7 @@
           </c:tx>
           <c:spPr>
             <a:solidFill>
-              <a:srgbClr val="FF785A"/>
+              <a:srgbClr val="E85D3F"/>
             </a:solidFill>
             <a:effectLst/>
           </c:spPr>
@@ -755,7 +755,7 @@
             <a:pPr>
               <a:defRPr sz="1300" b="0" i="0" u="none" strike="noStrike">
                 <a:solidFill>
-                  <a:srgbClr val="66718A"/>
+                  <a:srgbClr val="5B677F"/>
                 </a:solidFill>
                 <a:latin typeface="Arial"/>
               </a:defRPr>
@@ -809,7 +809,7 @@
             <a:pPr>
               <a:defRPr sz="1200" b="0" i="0" u="none" strike="noStrike">
                 <a:solidFill>
-                  <a:srgbClr val="66718A"/>
+                  <a:srgbClr val="5B677F"/>
                 </a:solidFill>
                 <a:latin typeface="Arial"/>
               </a:defRPr>
@@ -840,7 +840,7 @@
           <a:pPr>
             <a:defRPr sz="1300">
               <a:solidFill>
-                <a:srgbClr val="66718A"/>
+                <a:srgbClr val="5B677F"/>
               </a:solidFill>
             </a:defRPr>
           </a:pPr>
@@ -2408,7 +2408,7 @@
     <p:bg>
       <p:bgPr>
         <a:solidFill>
-          <a:srgbClr val="0A0F1E"/>
+          <a:srgbClr val="FFFFFF"/>
         </a:solidFill>
       </p:bgPr>
     </p:bg>
@@ -2453,7 +2453,7 @@
             <a:r>
               <a:rPr lang="en-US" sz="1400" b="1" spc="400" kern="0" dirty="0">
                 <a:solidFill>
-                  <a:srgbClr val="50A0FF"/>
+                  <a:srgbClr val="2B7FFF"/>
                 </a:solidFill>
                 <a:latin typeface="Arial" pitchFamily="34" charset="0"/>
                 <a:ea typeface="Arial" pitchFamily="34" charset="-122"/>
@@ -2492,7 +2492,7 @@
             <a:r>
               <a:rPr lang="en-US" sz="5400" b="1" dirty="0">
                 <a:solidFill>
-                  <a:srgbClr val="E8EEFA"/>
+                  <a:srgbClr val="182238"/>
                 </a:solidFill>
                 <a:latin typeface="Arial" pitchFamily="34" charset="0"/>
                 <a:ea typeface="Arial" pitchFamily="34" charset="-122"/>
@@ -2531,7 +2531,7 @@
             <a:r>
               <a:rPr lang="en-US" sz="2000" dirty="0">
                 <a:solidFill>
-                  <a:srgbClr val="8FA0C4"/>
+                  <a:srgbClr val="5B677F"/>
                 </a:solidFill>
                 <a:latin typeface="Arial" pitchFamily="34" charset="0"/>
                 <a:ea typeface="Arial" pitchFamily="34" charset="-122"/>
@@ -2560,11 +2560,11 @@
             </a:avLst>
           </a:prstGeom>
           <a:solidFill>
-            <a:srgbClr val="111A30"/>
+            <a:srgbClr val="F5F7FA"/>
           </a:solidFill>
           <a:ln w="12700">
             <a:solidFill>
-              <a:srgbClr val="2A3A5E"/>
+              <a:srgbClr val="D8DEE9"/>
             </a:solidFill>
             <a:prstDash val="solid"/>
           </a:ln>
@@ -2587,7 +2587,7 @@
           <a:noFill/>
           <a:ln w="12700">
             <a:solidFill>
-              <a:srgbClr val="2A3A5E"/>
+              <a:srgbClr val="D8DEE9"/>
             </a:solidFill>
             <a:prstDash val="dash"/>
           </a:ln>
@@ -2610,7 +2610,7 @@
             </a:avLst>
           </a:prstGeom>
           <a:solidFill>
-            <a:srgbClr val="50A0FF"/>
+            <a:srgbClr val="2B7FFF"/>
           </a:solidFill>
           <a:ln/>
         </p:spPr>
@@ -2654,7 +2654,7 @@
             </a:avLst>
           </a:prstGeom>
           <a:solidFill>
-            <a:srgbClr val="FF785A"/>
+            <a:srgbClr val="E85D3F"/>
           </a:solidFill>
           <a:ln/>
         </p:spPr>
@@ -2696,7 +2696,7 @@
             <a:avLst/>
           </a:prstGeom>
           <a:solidFill>
-            <a:srgbClr val="F2F2F2"/>
+            <a:srgbClr val="1C2A4A"/>
           </a:solidFill>
           <a:ln/>
         </p:spPr>
@@ -2728,7 +2728,7 @@
             <a:r>
               <a:rPr lang="en-US" sz="1200" dirty="0">
                 <a:solidFill>
-                  <a:srgbClr val="8FA0C4"/>
+                  <a:srgbClr val="5B677F"/>
                 </a:solidFill>
                 <a:latin typeface="Arial" pitchFamily="34" charset="0"/>
                 <a:ea typeface="Arial" pitchFamily="34" charset="-122"/>
@@ -2767,7 +2767,7 @@
             <a:r>
               <a:rPr lang="en-US" sz="1200" dirty="0">
                 <a:solidFill>
-                  <a:srgbClr val="8FA0C4"/>
+                  <a:srgbClr val="5B677F"/>
                 </a:solidFill>
                 <a:latin typeface="Arial" pitchFamily="34" charset="0"/>
                 <a:ea typeface="Arial" pitchFamily="34" charset="-122"/>
@@ -2793,7 +2793,7 @@
     <p:bg>
       <p:bgPr>
         <a:solidFill>
-          <a:srgbClr val="0A0F1E"/>
+          <a:srgbClr val="FFFFFF"/>
         </a:solidFill>
       </p:bgPr>
     </p:bg>
@@ -2838,7 +2838,7 @@
             <a:r>
               <a:rPr lang="en-US" sz="1400" b="1" spc="400" kern="0" dirty="0">
                 <a:solidFill>
-                  <a:srgbClr val="50A0FF"/>
+                  <a:srgbClr val="2B7FFF"/>
                 </a:solidFill>
                 <a:latin typeface="Arial" pitchFamily="34" charset="0"/>
                 <a:ea typeface="Arial" pitchFamily="34" charset="-122"/>
@@ -2877,7 +2877,7 @@
             <a:r>
               <a:rPr lang="en-US" sz="3600" b="1" dirty="0">
                 <a:solidFill>
-                  <a:srgbClr val="E8EEFA"/>
+                  <a:srgbClr val="182238"/>
                 </a:solidFill>
                 <a:latin typeface="Arial" pitchFamily="34" charset="0"/>
                 <a:ea typeface="Arial" pitchFamily="34" charset="-122"/>
@@ -2916,7 +2916,7 @@
             <a:r>
               <a:rPr lang="en-US" sz="1800" b="1" dirty="0">
                 <a:solidFill>
-                  <a:srgbClr val="E8EEFA"/>
+                  <a:srgbClr val="182238"/>
                 </a:solidFill>
                 <a:latin typeface="Arial" pitchFamily="34" charset="0"/>
                 <a:ea typeface="Arial" pitchFamily="34" charset="-122"/>
@@ -2955,7 +2955,7 @@
             <a:r>
               <a:rPr lang="en-US" sz="1500" dirty="0">
                 <a:solidFill>
-                  <a:srgbClr val="8FA0C4"/>
+                  <a:srgbClr val="5B677F"/>
                 </a:solidFill>
                 <a:latin typeface="Arial" pitchFamily="34" charset="0"/>
                 <a:ea typeface="Arial" pitchFamily="34" charset="-122"/>
@@ -2984,7 +2984,7 @@
           <a:noFill/>
           <a:ln w="9525">
             <a:solidFill>
-              <a:srgbClr val="2A3A5E"/>
+              <a:srgbClr val="D8DEE9"/>
             </a:solidFill>
             <a:prstDash val="solid"/>
           </a:ln>
@@ -3017,7 +3017,7 @@
             <a:r>
               <a:rPr lang="en-US" sz="1800" b="1" dirty="0">
                 <a:solidFill>
-                  <a:srgbClr val="E8EEFA"/>
+                  <a:srgbClr val="182238"/>
                 </a:solidFill>
                 <a:latin typeface="Arial" pitchFamily="34" charset="0"/>
                 <a:ea typeface="Arial" pitchFamily="34" charset="-122"/>
@@ -3056,7 +3056,7 @@
             <a:r>
               <a:rPr lang="en-US" sz="1500" dirty="0">
                 <a:solidFill>
-                  <a:srgbClr val="8FA0C4"/>
+                  <a:srgbClr val="5B677F"/>
                 </a:solidFill>
                 <a:latin typeface="Arial" pitchFamily="34" charset="0"/>
                 <a:ea typeface="Arial" pitchFamily="34" charset="-122"/>
@@ -3085,7 +3085,7 @@
           <a:noFill/>
           <a:ln w="9525">
             <a:solidFill>
-              <a:srgbClr val="2A3A5E"/>
+              <a:srgbClr val="D8DEE9"/>
             </a:solidFill>
             <a:prstDash val="solid"/>
           </a:ln>
@@ -3118,7 +3118,7 @@
             <a:r>
               <a:rPr lang="en-US" sz="1800" b="1" dirty="0">
                 <a:solidFill>
-                  <a:srgbClr val="E8EEFA"/>
+                  <a:srgbClr val="182238"/>
                 </a:solidFill>
                 <a:latin typeface="Arial" pitchFamily="34" charset="0"/>
                 <a:ea typeface="Arial" pitchFamily="34" charset="-122"/>
@@ -3157,7 +3157,7 @@
             <a:r>
               <a:rPr lang="en-US" sz="1500" dirty="0">
                 <a:solidFill>
-                  <a:srgbClr val="8FA0C4"/>
+                  <a:srgbClr val="5B677F"/>
                 </a:solidFill>
                 <a:latin typeface="Arial" pitchFamily="34" charset="0"/>
                 <a:ea typeface="Arial" pitchFamily="34" charset="-122"/>
@@ -3196,7 +3196,7 @@
             <a:r>
               <a:rPr lang="en-US" sz="1200" dirty="0">
                 <a:solidFill>
-                  <a:srgbClr val="8FA0C4"/>
+                  <a:srgbClr val="5B677F"/>
                 </a:solidFill>
                 <a:latin typeface="Arial" pitchFamily="34" charset="0"/>
                 <a:ea typeface="Arial" pitchFamily="34" charset="-122"/>
@@ -3267,7 +3267,7 @@
             <a:r>
               <a:rPr lang="en-US" sz="1200" b="1" spc="300" kern="0" dirty="0">
                 <a:solidFill>
-                  <a:srgbClr val="50A0FF"/>
+                  <a:srgbClr val="2B7FFF"/>
                 </a:solidFill>
                 <a:latin typeface="Arial" pitchFamily="34" charset="0"/>
                 <a:ea typeface="Arial" pitchFamily="34" charset="-122"/>
@@ -3335,11 +3335,11 @@
             </a:avLst>
           </a:prstGeom>
           <a:solidFill>
-            <a:srgbClr val="111A30"/>
+            <a:srgbClr val="F5F7FA"/>
           </a:solidFill>
           <a:ln w="12700">
             <a:solidFill>
-              <a:srgbClr val="2A3A5E"/>
+              <a:srgbClr val="D8DEE9"/>
             </a:solidFill>
             <a:prstDash val="solid"/>
           </a:ln>
@@ -3362,7 +3362,7 @@
           <a:noFill/>
           <a:ln w="12700">
             <a:solidFill>
-              <a:srgbClr val="2A3A5E"/>
+              <a:srgbClr val="D8DEE9"/>
             </a:solidFill>
             <a:prstDash val="dash"/>
           </a:ln>
@@ -3383,7 +3383,7 @@
             <a:avLst/>
           </a:prstGeom>
           <a:solidFill>
-            <a:srgbClr val="50A0FF">
+            <a:srgbClr val="2B7FFF">
               <a:alpha val="12000"/>
             </a:srgbClr>
           </a:solidFill>
@@ -3407,7 +3407,7 @@
             </a:avLst>
           </a:prstGeom>
           <a:solidFill>
-            <a:srgbClr val="50A0FF"/>
+            <a:srgbClr val="2B7FFF"/>
           </a:solidFill>
           <a:ln/>
         </p:spPr>
@@ -3451,7 +3451,7 @@
             </a:avLst>
           </a:prstGeom>
           <a:solidFill>
-            <a:srgbClr val="FF785A"/>
+            <a:srgbClr val="E85D3F"/>
           </a:solidFill>
           <a:ln/>
         </p:spPr>
@@ -3493,7 +3493,7 @@
             <a:avLst/>
           </a:prstGeom>
           <a:solidFill>
-            <a:srgbClr val="F2F2F2"/>
+            <a:srgbClr val="1C2A4A"/>
           </a:solidFill>
           <a:ln/>
         </p:spPr>
@@ -3525,7 +3525,7 @@
             <a:r>
               <a:rPr lang="en-US" sz="1200" dirty="0">
                 <a:solidFill>
-                  <a:srgbClr val="66718A"/>
+                  <a:srgbClr val="5B677F"/>
                 </a:solidFill>
                 <a:latin typeface="Arial" pitchFamily="34" charset="0"/>
                 <a:ea typeface="Arial" pitchFamily="34" charset="-122"/>
@@ -3603,7 +3603,7 @@
             <a:r>
               <a:rPr lang="en-US" sz="1400" dirty="0">
                 <a:solidFill>
-                  <a:srgbClr val="66718A"/>
+                  <a:srgbClr val="5B677F"/>
                 </a:solidFill>
                 <a:latin typeface="Arial" pitchFamily="34" charset="0"/>
                 <a:ea typeface="Arial" pitchFamily="34" charset="-122"/>
@@ -3704,7 +3704,7 @@
             <a:r>
               <a:rPr lang="en-US" sz="1400" dirty="0">
                 <a:solidFill>
-                  <a:srgbClr val="66718A"/>
+                  <a:srgbClr val="5B677F"/>
                 </a:solidFill>
                 <a:latin typeface="Arial" pitchFamily="34" charset="0"/>
                 <a:ea typeface="Arial" pitchFamily="34" charset="-122"/>
@@ -3805,7 +3805,7 @@
             <a:r>
               <a:rPr lang="en-US" sz="1400" dirty="0">
                 <a:solidFill>
-                  <a:srgbClr val="66718A"/>
+                  <a:srgbClr val="5B677F"/>
                 </a:solidFill>
                 <a:latin typeface="Arial" pitchFamily="34" charset="0"/>
                 <a:ea typeface="Arial" pitchFamily="34" charset="-122"/>
@@ -3906,7 +3906,7 @@
             <a:r>
               <a:rPr lang="en-US" sz="1400" dirty="0">
                 <a:solidFill>
-                  <a:srgbClr val="66718A"/>
+                  <a:srgbClr val="5B677F"/>
                 </a:solidFill>
                 <a:latin typeface="Arial" pitchFamily="34" charset="0"/>
                 <a:ea typeface="Arial" pitchFamily="34" charset="-122"/>
@@ -3977,7 +3977,7 @@
             <a:r>
               <a:rPr lang="en-US" sz="1200" b="1" spc="300" kern="0" dirty="0">
                 <a:solidFill>
-                  <a:srgbClr val="50A0FF"/>
+                  <a:srgbClr val="2B7FFF"/>
                 </a:solidFill>
                 <a:latin typeface="Arial" pitchFamily="34" charset="0"/>
                 <a:ea typeface="Arial" pitchFamily="34" charset="-122"/>
@@ -4077,7 +4077,7 @@
             <a:r>
               <a:rPr lang="en-US" sz="6600" b="1" dirty="0">
                 <a:solidFill>
-                  <a:srgbClr val="50A0FF"/>
+                  <a:srgbClr val="2B7FFF"/>
                 </a:solidFill>
                 <a:latin typeface="Arial" pitchFamily="34" charset="0"/>
                 <a:ea typeface="Arial" pitchFamily="34" charset="-122"/>
@@ -4155,7 +4155,7 @@
             <a:r>
               <a:rPr lang="en-US" sz="1250" dirty="0">
                 <a:solidFill>
-                  <a:srgbClr val="66718A"/>
+                  <a:srgbClr val="5B677F"/>
                 </a:solidFill>
                 <a:latin typeface="Arial" pitchFamily="34" charset="0"/>
                 <a:ea typeface="Arial" pitchFamily="34" charset="-122"/>
@@ -4216,7 +4216,7 @@
             <a:r>
               <a:rPr lang="en-US" sz="6600" b="1" dirty="0">
                 <a:solidFill>
-                  <a:srgbClr val="50A0FF"/>
+                  <a:srgbClr val="2B7FFF"/>
                 </a:solidFill>
                 <a:latin typeface="Arial" pitchFamily="34" charset="0"/>
                 <a:ea typeface="Arial" pitchFamily="34" charset="-122"/>
@@ -4294,7 +4294,7 @@
             <a:r>
               <a:rPr lang="en-US" sz="1250" dirty="0">
                 <a:solidFill>
-                  <a:srgbClr val="66718A"/>
+                  <a:srgbClr val="5B677F"/>
                 </a:solidFill>
                 <a:latin typeface="Arial" pitchFamily="34" charset="0"/>
                 <a:ea typeface="Arial" pitchFamily="34" charset="-122"/>
@@ -4355,7 +4355,7 @@
             <a:r>
               <a:rPr lang="en-US" sz="6600" b="1" dirty="0">
                 <a:solidFill>
-                  <a:srgbClr val="50A0FF"/>
+                  <a:srgbClr val="2B7FFF"/>
                 </a:solidFill>
                 <a:latin typeface="Arial" pitchFamily="34" charset="0"/>
                 <a:ea typeface="Arial" pitchFamily="34" charset="-122"/>
@@ -4433,7 +4433,7 @@
             <a:r>
               <a:rPr lang="en-US" sz="1250" dirty="0">
                 <a:solidFill>
-                  <a:srgbClr val="66718A"/>
+                  <a:srgbClr val="5B677F"/>
                 </a:solidFill>
                 <a:latin typeface="Arial" pitchFamily="34" charset="0"/>
                 <a:ea typeface="Arial" pitchFamily="34" charset="-122"/>
@@ -4494,7 +4494,7 @@
             <a:r>
               <a:rPr lang="en-US" sz="6600" b="1" dirty="0">
                 <a:solidFill>
-                  <a:srgbClr val="50A0FF"/>
+                  <a:srgbClr val="2B7FFF"/>
                 </a:solidFill>
                 <a:latin typeface="Arial" pitchFamily="34" charset="0"/>
                 <a:ea typeface="Arial" pitchFamily="34" charset="-122"/>
@@ -4572,7 +4572,7 @@
             <a:r>
               <a:rPr lang="en-US" sz="1250" dirty="0">
                 <a:solidFill>
-                  <a:srgbClr val="66718A"/>
+                  <a:srgbClr val="5B677F"/>
                 </a:solidFill>
                 <a:latin typeface="Arial" pitchFamily="34" charset="0"/>
                 <a:ea typeface="Arial" pitchFamily="34" charset="-122"/>
@@ -4650,7 +4650,7 @@
             <a:r>
               <a:rPr lang="en-US" sz="1100" dirty="0">
                 <a:solidFill>
-                  <a:srgbClr val="66718A"/>
+                  <a:srgbClr val="5B677F"/>
                 </a:solidFill>
                 <a:latin typeface="Arial" pitchFamily="34" charset="0"/>
                 <a:ea typeface="Arial" pitchFamily="34" charset="-122"/>
@@ -4721,7 +4721,7 @@
             <a:r>
               <a:rPr lang="en-US" sz="1200" b="1" spc="300" kern="0" dirty="0">
                 <a:solidFill>
-                  <a:srgbClr val="50A0FF"/>
+                  <a:srgbClr val="2B7FFF"/>
                 </a:solidFill>
                 <a:latin typeface="Arial" pitchFamily="34" charset="0"/>
                 <a:ea typeface="Arial" pitchFamily="34" charset="-122"/>
@@ -4823,7 +4823,7 @@
             <a:r>
               <a:rPr lang="en-US" sz="1200" i="1" dirty="0">
                 <a:solidFill>
-                  <a:srgbClr val="66718A"/>
+                  <a:srgbClr val="5B677F"/>
                 </a:solidFill>
                 <a:latin typeface="Arial" pitchFamily="34" charset="0"/>
                 <a:ea typeface="Arial" pitchFamily="34" charset="-122"/>
@@ -4986,7 +4986,7 @@
             <a:r>
               <a:rPr lang="en-US" sz="1600" i="1" dirty="0">
                 <a:solidFill>
-                  <a:srgbClr val="50A0FF"/>
+                  <a:srgbClr val="2B7FFF"/>
                 </a:solidFill>
                 <a:latin typeface="Arial" pitchFamily="34" charset="0"/>
                 <a:ea typeface="Arial" pitchFamily="34" charset="-122"/>
@@ -5025,7 +5025,7 @@
             <a:r>
               <a:rPr lang="en-US" sz="1100" dirty="0">
                 <a:solidFill>
-                  <a:srgbClr val="66718A"/>
+                  <a:srgbClr val="5B677F"/>
                 </a:solidFill>
                 <a:latin typeface="Arial" pitchFamily="34" charset="0"/>
                 <a:ea typeface="Arial" pitchFamily="34" charset="-122"/>
@@ -5096,7 +5096,7 @@
             <a:r>
               <a:rPr lang="en-US" sz="1200" b="1" spc="300" kern="0" dirty="0">
                 <a:solidFill>
-                  <a:srgbClr val="50A0FF"/>
+                  <a:srgbClr val="2B7FFF"/>
                 </a:solidFill>
                 <a:latin typeface="Arial" pitchFamily="34" charset="0"/>
                 <a:ea typeface="Arial" pitchFamily="34" charset="-122"/>
@@ -5212,7 +5212,7 @@
             <a:r>
               <a:rPr lang="en-US" sz="4000" b="1" dirty="0">
                 <a:solidFill>
-                  <a:srgbClr val="50A0FF"/>
+                  <a:srgbClr val="2B7FFF"/>
                 </a:solidFill>
                 <a:latin typeface="Arial" pitchFamily="34" charset="0"/>
                 <a:ea typeface="Arial" pitchFamily="34" charset="-122"/>
@@ -5329,7 +5329,7 @@
             <a:r>
               <a:rPr lang="en-US" sz="1100" dirty="0">
                 <a:solidFill>
-                  <a:srgbClr val="66718A"/>
+                  <a:srgbClr val="5B677F"/>
                 </a:solidFill>
                 <a:latin typeface="Arial" pitchFamily="34" charset="0"/>
                 <a:ea typeface="Arial" pitchFamily="34" charset="-122"/>
@@ -5400,7 +5400,7 @@
             <a:r>
               <a:rPr lang="en-US" sz="1200" b="1" spc="300" kern="0" dirty="0">
                 <a:solidFill>
-                  <a:srgbClr val="50A0FF"/>
+                  <a:srgbClr val="2B7FFF"/>
                 </a:solidFill>
                 <a:latin typeface="Arial" pitchFamily="34" charset="0"/>
                 <a:ea typeface="Arial" pitchFamily="34" charset="-122"/>
@@ -5502,7 +5502,7 @@
             <a:r>
               <a:rPr lang="en-US" sz="1300" i="1" dirty="0">
                 <a:solidFill>
-                  <a:srgbClr val="66718A"/>
+                  <a:srgbClr val="5B677F"/>
                 </a:solidFill>
                 <a:latin typeface="Arial" pitchFamily="34" charset="0"/>
                 <a:ea typeface="Arial" pitchFamily="34" charset="-122"/>
@@ -5580,7 +5580,7 @@
             <a:r>
               <a:rPr lang="en-US" sz="1100" dirty="0">
                 <a:solidFill>
-                  <a:srgbClr val="66718A"/>
+                  <a:srgbClr val="5B677F"/>
                 </a:solidFill>
                 <a:latin typeface="Arial" pitchFamily="34" charset="0"/>
                 <a:ea typeface="Arial" pitchFamily="34" charset="-122"/>
@@ -5651,7 +5651,7 @@
             <a:r>
               <a:rPr lang="en-US" sz="1200" b="1" spc="300" kern="0" dirty="0">
                 <a:solidFill>
-                  <a:srgbClr val="50A0FF"/>
+                  <a:srgbClr val="2B7FFF"/>
                 </a:solidFill>
                 <a:latin typeface="Arial" pitchFamily="34" charset="0"/>
                 <a:ea typeface="Arial" pitchFamily="34" charset="-122"/>
@@ -5753,7 +5753,7 @@
             <a:r>
               <a:rPr lang="en-US" sz="1200" i="1" dirty="0">
                 <a:solidFill>
-                  <a:srgbClr val="66718A"/>
+                  <a:srgbClr val="5B677F"/>
                 </a:solidFill>
                 <a:latin typeface="Arial" pitchFamily="34" charset="0"/>
                 <a:ea typeface="Arial" pitchFamily="34" charset="-122"/>
@@ -5814,7 +5814,7 @@
             <a:r>
               <a:rPr lang="en-US" sz="4000" b="1" dirty="0">
                 <a:solidFill>
-                  <a:srgbClr val="50A0FF"/>
+                  <a:srgbClr val="2B7FFF"/>
                 </a:solidFill>
                 <a:latin typeface="Arial" pitchFamily="34" charset="0"/>
                 <a:ea typeface="Arial" pitchFamily="34" charset="-122"/>
@@ -5955,7 +5955,7 @@
             <a:r>
               <a:rPr lang="en-US" sz="1100" dirty="0">
                 <a:solidFill>
-                  <a:srgbClr val="66718A"/>
+                  <a:srgbClr val="5B677F"/>
                 </a:solidFill>
                 <a:latin typeface="Arial" pitchFamily="34" charset="0"/>
                 <a:ea typeface="Arial" pitchFamily="34" charset="-122"/>
@@ -6026,7 +6026,7 @@
             <a:r>
               <a:rPr lang="en-US" sz="1200" b="1" spc="300" kern="0" dirty="0">
                 <a:solidFill>
-                  <a:srgbClr val="50A0FF"/>
+                  <a:srgbClr val="2B7FFF"/>
                 </a:solidFill>
                 <a:latin typeface="Arial" pitchFamily="34" charset="0"/>
                 <a:ea typeface="Arial" pitchFamily="34" charset="-122"/>
@@ -6244,7 +6244,7 @@
             <a:r>
               <a:rPr lang="en-US" sz="1100" dirty="0">
                 <a:solidFill>
-                  <a:srgbClr val="66718A"/>
+                  <a:srgbClr val="5B677F"/>
                 </a:solidFill>
                 <a:latin typeface="Arial" pitchFamily="34" charset="0"/>
                 <a:ea typeface="Arial" pitchFamily="34" charset="-122"/>
@@ -6270,7 +6270,7 @@
     <p:bg>
       <p:bgPr>
         <a:solidFill>
-          <a:srgbClr val="0A0F1E"/>
+          <a:srgbClr val="FFFFFF"/>
         </a:solidFill>
       </p:bgPr>
     </p:bg>
@@ -6315,7 +6315,7 @@
             <a:r>
               <a:rPr lang="en-US" sz="1400" b="1" spc="400" kern="0" dirty="0">
                 <a:solidFill>
-                  <a:srgbClr val="50A0FF"/>
+                  <a:srgbClr val="2B7FFF"/>
                 </a:solidFill>
                 <a:latin typeface="Arial" pitchFamily="34" charset="0"/>
                 <a:ea typeface="Arial" pitchFamily="34" charset="-122"/>
@@ -6354,7 +6354,7 @@
             <a:r>
               <a:rPr lang="en-US" sz="6400" b="1" dirty="0">
                 <a:solidFill>
-                  <a:srgbClr val="E8EEFA"/>
+                  <a:srgbClr val="182238"/>
                 </a:solidFill>
                 <a:latin typeface="Arial" pitchFamily="34" charset="0"/>
                 <a:ea typeface="Arial" pitchFamily="34" charset="-122"/>
@@ -6393,7 +6393,7 @@
             <a:r>
               <a:rPr lang="en-US" sz="2000" dirty="0">
                 <a:solidFill>
-                  <a:srgbClr val="8FA0C4"/>
+                  <a:srgbClr val="5B677F"/>
                 </a:solidFill>
                 <a:latin typeface="Arial" pitchFamily="34" charset="0"/>
                 <a:ea typeface="Arial" pitchFamily="34" charset="-122"/>
@@ -6432,7 +6432,7 @@
             <a:r>
               <a:rPr lang="en-US" sz="2000" b="1" dirty="0">
                 <a:solidFill>
-                  <a:srgbClr val="50A0FF"/>
+                  <a:srgbClr val="2B7FFF"/>
                 </a:solidFill>
                 <a:latin typeface="Arial" pitchFamily="34" charset="0"/>
                 <a:ea typeface="Arial" pitchFamily="34" charset="-122"/>
@@ -6471,7 +6471,7 @@
             <a:r>
               <a:rPr lang="en-US" sz="1350" dirty="0">
                 <a:solidFill>
-                  <a:srgbClr val="8FA0C4"/>
+                  <a:srgbClr val="5B677F"/>
                 </a:solidFill>
                 <a:latin typeface="Arial" pitchFamily="34" charset="0"/>
                 <a:ea typeface="Arial" pitchFamily="34" charset="-122"/>
@@ -6510,7 +6510,7 @@
             <a:r>
               <a:rPr lang="en-US" sz="2000" b="1" dirty="0">
                 <a:solidFill>
-                  <a:srgbClr val="50A0FF"/>
+                  <a:srgbClr val="2B7FFF"/>
                 </a:solidFill>
                 <a:latin typeface="Arial" pitchFamily="34" charset="0"/>
                 <a:ea typeface="Arial" pitchFamily="34" charset="-122"/>
@@ -6549,7 +6549,7 @@
             <a:r>
               <a:rPr lang="en-US" sz="1350" dirty="0">
                 <a:solidFill>
-                  <a:srgbClr val="8FA0C4"/>
+                  <a:srgbClr val="5B677F"/>
                 </a:solidFill>
                 <a:latin typeface="Arial" pitchFamily="34" charset="0"/>
                 <a:ea typeface="Arial" pitchFamily="34" charset="-122"/>
@@ -6588,7 +6588,7 @@
             <a:r>
               <a:rPr lang="en-US" sz="2000" b="1" dirty="0">
                 <a:solidFill>
-                  <a:srgbClr val="50A0FF"/>
+                  <a:srgbClr val="2B7FFF"/>
                 </a:solidFill>
                 <a:latin typeface="Arial" pitchFamily="34" charset="0"/>
                 <a:ea typeface="Arial" pitchFamily="34" charset="-122"/>
@@ -6627,7 +6627,7 @@
             <a:r>
               <a:rPr lang="en-US" sz="1350" dirty="0">
                 <a:solidFill>
-                  <a:srgbClr val="8FA0C4"/>
+                  <a:srgbClr val="5B677F"/>
                 </a:solidFill>
                 <a:latin typeface="Arial" pitchFamily="34" charset="0"/>
                 <a:ea typeface="Arial" pitchFamily="34" charset="-122"/>

</xml_diff>